<commit_message>
cv2: uloha 8 jako bonus
</commit_message>
<xml_diff>
--- a/cviceni/cv2/uvin_cv2.pptx
+++ b/cviceni/cv2/uvin_cv2.pptx
@@ -372,7 +372,7 @@
             <a:pPr indent="0" algn="r">
               <a:buNone/>
             </a:pPr>
-            <a:fld id="{9EE2E0C3-73E3-4A6C-B945-65108A079ED2}" type="slidenum">
+            <a:fld id="{E486D045-1D29-42ED-BA1B-18D1927B416B}" type="slidenum">
               <a:rPr lang="en-US" sz="1400" b="0" u="none" strike="noStrike">
                 <a:solidFill>
                   <a:srgbClr val="000000"/>
@@ -430,7 +430,7 @@
         <p:spPr>
           <a:xfrm>
             <a:off x="-228600" y="1523880"/>
-            <a:ext cx="7314840" cy="4114440"/>
+            <a:ext cx="7314480" cy="4114080"/>
           </a:xfrm>
           <a:prstGeom prst="rect">
             <a:avLst/>
@@ -453,7 +453,7 @@
         <p:spPr>
           <a:xfrm>
             <a:off x="685800" y="5867280"/>
-            <a:ext cx="5486040" cy="4800240"/>
+            <a:ext cx="5485680" cy="4799880"/>
           </a:xfrm>
           <a:prstGeom prst="rect">
             <a:avLst/>
@@ -495,7 +495,7 @@
         <p:spPr>
           <a:xfrm>
             <a:off x="3884760" y="11580840"/>
-            <a:ext cx="2971440" cy="610920"/>
+            <a:ext cx="2971080" cy="610560"/>
           </a:xfrm>
           <a:prstGeom prst="rect">
             <a:avLst/>
@@ -515,6 +515,9 @@
                 <a:spcPct val="100000"/>
               </a:lnSpc>
               <a:buNone/>
+              <a:tabLst>
+                <a:tab pos="0" algn="l"/>
+              </a:tabLst>
               <a:defRPr lang="en-US" sz="1200" b="0" u="none" strike="noStrike">
                 <a:solidFill>
                   <a:schemeClr val="dk1"/>
@@ -532,8 +535,11 @@
                 <a:spcPct val="100000"/>
               </a:lnSpc>
               <a:buNone/>
-            </a:pPr>
-            <a:fld id="{E649A201-D718-486B-A5FA-780CFC3CAFDA}" type="slidenum">
+              <a:tabLst>
+                <a:tab pos="0" algn="l"/>
+              </a:tabLst>
+            </a:pPr>
+            <a:fld id="{E1EEAD33-AAF2-4192-A701-D5707015506E}" type="slidenum">
               <a:rPr lang="en-US" sz="1200" b="0" u="none" strike="noStrike">
                 <a:solidFill>
                   <a:schemeClr val="dk1"/>
@@ -543,7 +549,7 @@
                 <a:latin typeface="+mn-lt"/>
                 <a:ea typeface="+mn-ea"/>
               </a:rPr>
-              <a:t>1</a:t>
+              <a:t>&lt;number&gt;</a:t>
             </a:fld>
             <a:endParaRPr lang="en-US" sz="1200" b="0" u="none" strike="noStrike">
               <a:solidFill>
@@ -591,7 +597,7 @@
         <p:spPr>
           <a:xfrm>
             <a:off x="-228600" y="1523880"/>
-            <a:ext cx="7314840" cy="4114440"/>
+            <a:ext cx="7314480" cy="4114080"/>
           </a:xfrm>
           <a:prstGeom prst="rect">
             <a:avLst/>
@@ -614,7 +620,7 @@
         <p:spPr>
           <a:xfrm>
             <a:off x="685800" y="5867280"/>
-            <a:ext cx="5486040" cy="4800240"/>
+            <a:ext cx="5485680" cy="4799880"/>
           </a:xfrm>
           <a:prstGeom prst="rect">
             <a:avLst/>
@@ -656,7 +662,7 @@
         <p:spPr>
           <a:xfrm>
             <a:off x="3884760" y="11580840"/>
-            <a:ext cx="2971440" cy="610920"/>
+            <a:ext cx="2971080" cy="610560"/>
           </a:xfrm>
           <a:prstGeom prst="rect">
             <a:avLst/>
@@ -676,6 +682,9 @@
                 <a:spcPct val="100000"/>
               </a:lnSpc>
               <a:buNone/>
+              <a:tabLst>
+                <a:tab pos="0" algn="l"/>
+              </a:tabLst>
               <a:defRPr lang="en-US" sz="1200" b="0" u="none" strike="noStrike">
                 <a:solidFill>
                   <a:schemeClr val="dk1"/>
@@ -693,8 +702,11 @@
                 <a:spcPct val="100000"/>
               </a:lnSpc>
               <a:buNone/>
-            </a:pPr>
-            <a:fld id="{83E97554-E8BD-4D22-A9AE-4303E0D19AF1}" type="slidenum">
+              <a:tabLst>
+                <a:tab pos="0" algn="l"/>
+              </a:tabLst>
+            </a:pPr>
+            <a:fld id="{CF014154-F525-4C05-9A4F-1D82B66CE361}" type="slidenum">
               <a:rPr lang="en-US" sz="1200" b="0" u="none" strike="noStrike">
                 <a:solidFill>
                   <a:schemeClr val="dk1"/>
@@ -704,7 +716,7 @@
                 <a:latin typeface="+mn-lt"/>
                 <a:ea typeface="+mn-ea"/>
               </a:rPr>
-              <a:t>1</a:t>
+              <a:t>&lt;number&gt;</a:t>
             </a:fld>
             <a:endParaRPr lang="en-US" sz="1200" b="0" u="none" strike="noStrike">
               <a:solidFill>
@@ -752,7 +764,7 @@
         <p:spPr>
           <a:xfrm>
             <a:off x="-228600" y="1523880"/>
-            <a:ext cx="7314840" cy="4114440"/>
+            <a:ext cx="7314480" cy="4114080"/>
           </a:xfrm>
           <a:prstGeom prst="rect">
             <a:avLst/>
@@ -775,7 +787,7 @@
         <p:spPr>
           <a:xfrm>
             <a:off x="685800" y="5867280"/>
-            <a:ext cx="5486040" cy="4800240"/>
+            <a:ext cx="5485680" cy="4799880"/>
           </a:xfrm>
           <a:prstGeom prst="rect">
             <a:avLst/>
@@ -817,7 +829,7 @@
         <p:spPr>
           <a:xfrm>
             <a:off x="3884760" y="11580840"/>
-            <a:ext cx="2971440" cy="610920"/>
+            <a:ext cx="2971080" cy="610560"/>
           </a:xfrm>
           <a:prstGeom prst="rect">
             <a:avLst/>
@@ -837,6 +849,9 @@
                 <a:spcPct val="100000"/>
               </a:lnSpc>
               <a:buNone/>
+              <a:tabLst>
+                <a:tab pos="0" algn="l"/>
+              </a:tabLst>
               <a:defRPr lang="en-US" sz="1200" b="0" u="none" strike="noStrike">
                 <a:solidFill>
                   <a:schemeClr val="dk1"/>
@@ -854,8 +869,11 @@
                 <a:spcPct val="100000"/>
               </a:lnSpc>
               <a:buNone/>
-            </a:pPr>
-            <a:fld id="{E001112B-D803-4F92-8EE1-84712CDF32D0}" type="slidenum">
+              <a:tabLst>
+                <a:tab pos="0" algn="l"/>
+              </a:tabLst>
+            </a:pPr>
+            <a:fld id="{013CE2D8-E554-45FE-BB2B-5D4134F11D61}" type="slidenum">
               <a:rPr lang="en-US" sz="1200" b="0" u="none" strike="noStrike">
                 <a:solidFill>
                   <a:schemeClr val="dk1"/>
@@ -865,7 +883,7 @@
                 <a:latin typeface="+mn-lt"/>
                 <a:ea typeface="+mn-ea"/>
               </a:rPr>
-              <a:t>1</a:t>
+              <a:t>&lt;number&gt;</a:t>
             </a:fld>
             <a:endParaRPr lang="en-US" sz="1200" b="0" u="none" strike="noStrike">
               <a:solidFill>
@@ -913,7 +931,7 @@
         <p:spPr>
           <a:xfrm>
             <a:off x="-228600" y="1523880"/>
-            <a:ext cx="7314840" cy="4114440"/>
+            <a:ext cx="7314480" cy="4114080"/>
           </a:xfrm>
           <a:prstGeom prst="rect">
             <a:avLst/>
@@ -936,7 +954,7 @@
         <p:spPr>
           <a:xfrm>
             <a:off x="685800" y="5867280"/>
-            <a:ext cx="5486040" cy="4800240"/>
+            <a:ext cx="5485680" cy="4799880"/>
           </a:xfrm>
           <a:prstGeom prst="rect">
             <a:avLst/>
@@ -978,7 +996,7 @@
         <p:spPr>
           <a:xfrm>
             <a:off x="3884760" y="11580840"/>
-            <a:ext cx="2971440" cy="610920"/>
+            <a:ext cx="2971080" cy="610560"/>
           </a:xfrm>
           <a:prstGeom prst="rect">
             <a:avLst/>
@@ -998,6 +1016,9 @@
                 <a:spcPct val="100000"/>
               </a:lnSpc>
               <a:buNone/>
+              <a:tabLst>
+                <a:tab pos="0" algn="l"/>
+              </a:tabLst>
               <a:defRPr lang="en-US" sz="1200" b="0" u="none" strike="noStrike">
                 <a:solidFill>
                   <a:schemeClr val="dk1"/>
@@ -1015,8 +1036,11 @@
                 <a:spcPct val="100000"/>
               </a:lnSpc>
               <a:buNone/>
-            </a:pPr>
-            <a:fld id="{D29B7D10-503C-4DE8-A64B-EC8890507246}" type="slidenum">
+              <a:tabLst>
+                <a:tab pos="0" algn="l"/>
+              </a:tabLst>
+            </a:pPr>
+            <a:fld id="{A7A90EA3-8356-4298-99E5-522CEBD40A5D}" type="slidenum">
               <a:rPr lang="en-US" sz="1200" b="0" u="none" strike="noStrike">
                 <a:solidFill>
                   <a:schemeClr val="dk1"/>
@@ -1026,7 +1050,7 @@
                 <a:latin typeface="+mn-lt"/>
                 <a:ea typeface="+mn-ea"/>
               </a:rPr>
-              <a:t>1</a:t>
+              <a:t>&lt;number&gt;</a:t>
             </a:fld>
             <a:endParaRPr lang="en-US" sz="1200" b="0" u="none" strike="noStrike">
               <a:solidFill>
@@ -1074,7 +1098,7 @@
         <p:spPr>
           <a:xfrm>
             <a:off x="-228600" y="1523880"/>
-            <a:ext cx="7314840" cy="4114440"/>
+            <a:ext cx="7314480" cy="4114080"/>
           </a:xfrm>
           <a:prstGeom prst="rect">
             <a:avLst/>
@@ -1097,7 +1121,7 @@
         <p:spPr>
           <a:xfrm>
             <a:off x="685800" y="5867280"/>
-            <a:ext cx="5486040" cy="4800240"/>
+            <a:ext cx="5485680" cy="4799880"/>
           </a:xfrm>
           <a:prstGeom prst="rect">
             <a:avLst/>
@@ -1139,7 +1163,7 @@
         <p:spPr>
           <a:xfrm>
             <a:off x="3884760" y="11580840"/>
-            <a:ext cx="2971440" cy="610920"/>
+            <a:ext cx="2971080" cy="610560"/>
           </a:xfrm>
           <a:prstGeom prst="rect">
             <a:avLst/>
@@ -1159,6 +1183,9 @@
                 <a:spcPct val="100000"/>
               </a:lnSpc>
               <a:buNone/>
+              <a:tabLst>
+                <a:tab pos="0" algn="l"/>
+              </a:tabLst>
               <a:defRPr lang="en-US" sz="1200" b="0" u="none" strike="noStrike">
                 <a:solidFill>
                   <a:schemeClr val="dk1"/>
@@ -1176,8 +1203,11 @@
                 <a:spcPct val="100000"/>
               </a:lnSpc>
               <a:buNone/>
-            </a:pPr>
-            <a:fld id="{54F9CBAD-CA30-4125-9D32-0F5BCDBA9E1A}" type="slidenum">
+              <a:tabLst>
+                <a:tab pos="0" algn="l"/>
+              </a:tabLst>
+            </a:pPr>
+            <a:fld id="{75D827D9-A9A7-4F28-88E6-15041EBD6ADA}" type="slidenum">
               <a:rPr lang="en-US" sz="1200" b="0" u="none" strike="noStrike">
                 <a:solidFill>
                   <a:schemeClr val="dk1"/>
@@ -1187,7 +1217,7 @@
                 <a:latin typeface="+mn-lt"/>
                 <a:ea typeface="+mn-ea"/>
               </a:rPr>
-              <a:t>1</a:t>
+              <a:t>&lt;number&gt;</a:t>
             </a:fld>
             <a:endParaRPr lang="en-US" sz="1200" b="0" u="none" strike="noStrike">
               <a:solidFill>
@@ -1235,7 +1265,7 @@
         <p:spPr>
           <a:xfrm>
             <a:off x="-228600" y="1523880"/>
-            <a:ext cx="7314840" cy="4114440"/>
+            <a:ext cx="7314480" cy="4114080"/>
           </a:xfrm>
           <a:prstGeom prst="rect">
             <a:avLst/>
@@ -1258,7 +1288,7 @@
         <p:spPr>
           <a:xfrm>
             <a:off x="685800" y="5867280"/>
-            <a:ext cx="5486040" cy="4800240"/>
+            <a:ext cx="5485680" cy="4799880"/>
           </a:xfrm>
           <a:prstGeom prst="rect">
             <a:avLst/>
@@ -1300,7 +1330,7 @@
         <p:spPr>
           <a:xfrm>
             <a:off x="3884760" y="11580840"/>
-            <a:ext cx="2971440" cy="610920"/>
+            <a:ext cx="2971080" cy="610560"/>
           </a:xfrm>
           <a:prstGeom prst="rect">
             <a:avLst/>
@@ -1320,6 +1350,9 @@
                 <a:spcPct val="100000"/>
               </a:lnSpc>
               <a:buNone/>
+              <a:tabLst>
+                <a:tab pos="0" algn="l"/>
+              </a:tabLst>
               <a:defRPr lang="en-US" sz="1200" b="0" u="none" strike="noStrike">
                 <a:solidFill>
                   <a:schemeClr val="dk1"/>
@@ -1337,8 +1370,11 @@
                 <a:spcPct val="100000"/>
               </a:lnSpc>
               <a:buNone/>
-            </a:pPr>
-            <a:fld id="{44B49E6E-267B-44D2-8227-430C2AE2A244}" type="slidenum">
+              <a:tabLst>
+                <a:tab pos="0" algn="l"/>
+              </a:tabLst>
+            </a:pPr>
+            <a:fld id="{FD74F47E-5B5E-46B5-B51F-3361B624F107}" type="slidenum">
               <a:rPr lang="en-US" sz="1200" b="0" u="none" strike="noStrike">
                 <a:solidFill>
                   <a:schemeClr val="dk1"/>
@@ -1348,7 +1384,7 @@
                 <a:latin typeface="+mn-lt"/>
                 <a:ea typeface="+mn-ea"/>
               </a:rPr>
-              <a:t>1</a:t>
+              <a:t>&lt;number&gt;</a:t>
             </a:fld>
             <a:endParaRPr lang="en-US" sz="1200" b="0" u="none" strike="noStrike">
               <a:solidFill>
@@ -1396,7 +1432,7 @@
         <p:spPr>
           <a:xfrm>
             <a:off x="-228600" y="1523880"/>
-            <a:ext cx="7314840" cy="4114440"/>
+            <a:ext cx="7314480" cy="4114080"/>
           </a:xfrm>
           <a:prstGeom prst="rect">
             <a:avLst/>
@@ -1419,7 +1455,7 @@
         <p:spPr>
           <a:xfrm>
             <a:off x="685800" y="5867280"/>
-            <a:ext cx="5486040" cy="4800240"/>
+            <a:ext cx="5485680" cy="4799880"/>
           </a:xfrm>
           <a:prstGeom prst="rect">
             <a:avLst/>
@@ -1461,7 +1497,7 @@
         <p:spPr>
           <a:xfrm>
             <a:off x="3884760" y="11580840"/>
-            <a:ext cx="2971440" cy="610920"/>
+            <a:ext cx="2971080" cy="610560"/>
           </a:xfrm>
           <a:prstGeom prst="rect">
             <a:avLst/>
@@ -1481,6 +1517,9 @@
                 <a:spcPct val="100000"/>
               </a:lnSpc>
               <a:buNone/>
+              <a:tabLst>
+                <a:tab pos="0" algn="l"/>
+              </a:tabLst>
               <a:defRPr lang="en-US" sz="1200" b="0" u="none" strike="noStrike">
                 <a:solidFill>
                   <a:schemeClr val="dk1"/>
@@ -1498,8 +1537,11 @@
                 <a:spcPct val="100000"/>
               </a:lnSpc>
               <a:buNone/>
-            </a:pPr>
-            <a:fld id="{147F3392-C7B6-4AC4-9B24-DCFB30574DA1}" type="slidenum">
+              <a:tabLst>
+                <a:tab pos="0" algn="l"/>
+              </a:tabLst>
+            </a:pPr>
+            <a:fld id="{CB23DC0D-5434-46A8-BE75-6A48BDCE8B11}" type="slidenum">
               <a:rPr lang="en-US" sz="1200" b="0" u="none" strike="noStrike">
                 <a:solidFill>
                   <a:schemeClr val="dk1"/>
@@ -1509,7 +1551,7 @@
                 <a:latin typeface="+mn-lt"/>
                 <a:ea typeface="+mn-ea"/>
               </a:rPr>
-              <a:t>1</a:t>
+              <a:t>&lt;number&gt;</a:t>
             </a:fld>
             <a:endParaRPr lang="en-US" sz="1200" b="0" u="none" strike="noStrike">
               <a:solidFill>
@@ -1557,7 +1599,7 @@
         <p:spPr>
           <a:xfrm>
             <a:off x="-228600" y="1523880"/>
-            <a:ext cx="7314840" cy="4114440"/>
+            <a:ext cx="7314480" cy="4114080"/>
           </a:xfrm>
           <a:prstGeom prst="rect">
             <a:avLst/>
@@ -1580,7 +1622,7 @@
         <p:spPr>
           <a:xfrm>
             <a:off x="685800" y="5867280"/>
-            <a:ext cx="5486040" cy="4800240"/>
+            <a:ext cx="5485680" cy="4799880"/>
           </a:xfrm>
           <a:prstGeom prst="rect">
             <a:avLst/>
@@ -1622,7 +1664,7 @@
         <p:spPr>
           <a:xfrm>
             <a:off x="3884760" y="11580840"/>
-            <a:ext cx="2971440" cy="610920"/>
+            <a:ext cx="2971080" cy="610560"/>
           </a:xfrm>
           <a:prstGeom prst="rect">
             <a:avLst/>
@@ -1642,6 +1684,9 @@
                 <a:spcPct val="100000"/>
               </a:lnSpc>
               <a:buNone/>
+              <a:tabLst>
+                <a:tab pos="0" algn="l"/>
+              </a:tabLst>
               <a:defRPr lang="en-US" sz="1200" b="0" u="none" strike="noStrike">
                 <a:solidFill>
                   <a:schemeClr val="dk1"/>
@@ -1659,8 +1704,11 @@
                 <a:spcPct val="100000"/>
               </a:lnSpc>
               <a:buNone/>
-            </a:pPr>
-            <a:fld id="{507A151C-7CF5-46C0-A995-A28104146035}" type="slidenum">
+              <a:tabLst>
+                <a:tab pos="0" algn="l"/>
+              </a:tabLst>
+            </a:pPr>
+            <a:fld id="{53BBF65C-D8AA-4A46-9966-E5EBD9C158D1}" type="slidenum">
               <a:rPr lang="en-US" sz="1200" b="0" u="none" strike="noStrike">
                 <a:solidFill>
                   <a:schemeClr val="dk1"/>
@@ -1670,7 +1718,7 @@
                 <a:latin typeface="+mn-lt"/>
                 <a:ea typeface="+mn-ea"/>
               </a:rPr>
-              <a:t>1</a:t>
+              <a:t>&lt;number&gt;</a:t>
             </a:fld>
             <a:endParaRPr lang="en-US" sz="1200" b="0" u="none" strike="noStrike">
               <a:solidFill>
@@ -1718,7 +1766,7 @@
         <p:spPr>
           <a:xfrm>
             <a:off x="-228600" y="1523880"/>
-            <a:ext cx="7314840" cy="4114440"/>
+            <a:ext cx="7314480" cy="4114080"/>
           </a:xfrm>
           <a:prstGeom prst="rect">
             <a:avLst/>
@@ -1741,7 +1789,7 @@
         <p:spPr>
           <a:xfrm>
             <a:off x="685800" y="5867280"/>
-            <a:ext cx="5486040" cy="4800240"/>
+            <a:ext cx="5485680" cy="4799880"/>
           </a:xfrm>
           <a:prstGeom prst="rect">
             <a:avLst/>
@@ -1783,7 +1831,7 @@
         <p:spPr>
           <a:xfrm>
             <a:off x="3884760" y="11580840"/>
-            <a:ext cx="2971440" cy="610920"/>
+            <a:ext cx="2971080" cy="610560"/>
           </a:xfrm>
           <a:prstGeom prst="rect">
             <a:avLst/>
@@ -1803,6 +1851,9 @@
                 <a:spcPct val="100000"/>
               </a:lnSpc>
               <a:buNone/>
+              <a:tabLst>
+                <a:tab pos="0" algn="l"/>
+              </a:tabLst>
               <a:defRPr lang="en-US" sz="1200" b="0" u="none" strike="noStrike">
                 <a:solidFill>
                   <a:schemeClr val="dk1"/>
@@ -1820,8 +1871,11 @@
                 <a:spcPct val="100000"/>
               </a:lnSpc>
               <a:buNone/>
-            </a:pPr>
-            <a:fld id="{66FB5BDF-4C12-4B90-9F98-41CF25648312}" type="slidenum">
+              <a:tabLst>
+                <a:tab pos="0" algn="l"/>
+              </a:tabLst>
+            </a:pPr>
+            <a:fld id="{BBE09E4F-1455-4308-9CB1-4E087D46B877}" type="slidenum">
               <a:rPr lang="en-US" sz="1200" b="0" u="none" strike="noStrike">
                 <a:solidFill>
                   <a:schemeClr val="dk1"/>
@@ -1928,6 +1982,9 @@
           <a:lstStyle>
             <a:lvl1pPr indent="0" algn="l">
               <a:buNone/>
+              <a:tabLst>
+                <a:tab pos="0" algn="l"/>
+              </a:tabLst>
               <a:defRPr lang="en-US" sz="1800" b="0" u="none" strike="noStrike">
                 <a:solidFill>
                   <a:schemeClr val="dk1"/>
@@ -1941,6 +1998,9 @@
           <a:p>
             <a:pPr indent="0" algn="l">
               <a:buNone/>
+              <a:tabLst>
+                <a:tab pos="0" algn="l"/>
+              </a:tabLst>
             </a:pPr>
             <a:r>
               <a:rPr lang="en-US" sz="1800" b="0" u="none" strike="noStrike">
@@ -2127,7 +2187,7 @@
             </a:lvl7pPr>
           </a:lstStyle>
           <a:p>
-            <a:pPr marL="432000" indent="-324000" algn="l">
+            <a:pPr indent="-324000" algn="l">
               <a:spcBef>
                 <a:spcPts val="1417"/>
               </a:spcBef>
@@ -2394,7 +2454,7 @@
         <p:spPr>
           <a:xfrm>
             <a:off x="640080" y="1828800"/>
-            <a:ext cx="10972440" cy="731160"/>
+            <a:ext cx="10972080" cy="730800"/>
           </a:xfrm>
           <a:prstGeom prst="rect">
             <a:avLst/>
@@ -2454,7 +2514,7 @@
         <p:spPr>
           <a:xfrm>
             <a:off x="1828800" y="2926080"/>
-            <a:ext cx="8229240" cy="456840"/>
+            <a:ext cx="8228880" cy="456480"/>
           </a:xfrm>
           <a:prstGeom prst="rect">
             <a:avLst/>
@@ -2544,7 +2604,7 @@
         <p:spPr>
           <a:xfrm>
             <a:off x="457200" y="457200"/>
-            <a:ext cx="10972440" cy="360"/>
+            <a:ext cx="10972080" cy="360"/>
           </a:xfrm>
           <a:prstGeom prst="rect">
             <a:avLst/>
@@ -2604,7 +2664,7 @@
         <p:spPr>
           <a:xfrm>
             <a:off x="731520" y="1280160"/>
-            <a:ext cx="10058040" cy="1828440"/>
+            <a:ext cx="10057680" cy="1828080"/>
           </a:xfrm>
           <a:prstGeom prst="rect">
             <a:avLst/>
@@ -2664,7 +2724,7 @@
         <p:spPr>
           <a:xfrm>
             <a:off x="731520" y="4114800"/>
-            <a:ext cx="10058040" cy="360"/>
+            <a:ext cx="10057680" cy="360"/>
           </a:xfrm>
           <a:prstGeom prst="rect">
             <a:avLst/>
@@ -2754,7 +2814,7 @@
         <p:spPr>
           <a:xfrm>
             <a:off x="457200" y="457200"/>
-            <a:ext cx="10972440" cy="360"/>
+            <a:ext cx="10972080" cy="360"/>
           </a:xfrm>
           <a:prstGeom prst="rect">
             <a:avLst/>
@@ -2814,7 +2874,7 @@
         <p:spPr>
           <a:xfrm>
             <a:off x="731520" y="1280160"/>
-            <a:ext cx="10058040" cy="1828440"/>
+            <a:ext cx="10057680" cy="1828080"/>
           </a:xfrm>
           <a:prstGeom prst="rect">
             <a:avLst/>
@@ -2874,7 +2934,7 @@
         <p:spPr>
           <a:xfrm>
             <a:off x="731520" y="4114800"/>
-            <a:ext cx="10058040" cy="360"/>
+            <a:ext cx="10057680" cy="360"/>
           </a:xfrm>
           <a:prstGeom prst="rect">
             <a:avLst/>
@@ -2964,7 +3024,7 @@
         <p:spPr>
           <a:xfrm>
             <a:off x="457200" y="457200"/>
-            <a:ext cx="10972440" cy="360"/>
+            <a:ext cx="10972080" cy="360"/>
           </a:xfrm>
           <a:prstGeom prst="rect">
             <a:avLst/>
@@ -3024,7 +3084,7 @@
         <p:spPr>
           <a:xfrm>
             <a:off x="731520" y="1280160"/>
-            <a:ext cx="10058040" cy="1828440"/>
+            <a:ext cx="10057680" cy="1828080"/>
           </a:xfrm>
           <a:prstGeom prst="rect">
             <a:avLst/>
@@ -3084,7 +3144,7 @@
         <p:spPr>
           <a:xfrm>
             <a:off x="731520" y="4114800"/>
-            <a:ext cx="10058040" cy="360"/>
+            <a:ext cx="10057680" cy="360"/>
           </a:xfrm>
           <a:prstGeom prst="rect">
             <a:avLst/>
@@ -3174,7 +3234,7 @@
         <p:spPr>
           <a:xfrm>
             <a:off x="457200" y="457200"/>
-            <a:ext cx="10972440" cy="360"/>
+            <a:ext cx="10972080" cy="360"/>
           </a:xfrm>
           <a:prstGeom prst="rect">
             <a:avLst/>
@@ -3234,7 +3294,7 @@
         <p:spPr>
           <a:xfrm>
             <a:off x="731520" y="1280160"/>
-            <a:ext cx="10058040" cy="1828440"/>
+            <a:ext cx="10057680" cy="1828080"/>
           </a:xfrm>
           <a:prstGeom prst="rect">
             <a:avLst/>
@@ -3294,7 +3354,7 @@
         <p:spPr>
           <a:xfrm>
             <a:off x="731520" y="4114800"/>
-            <a:ext cx="10058040" cy="360"/>
+            <a:ext cx="10057680" cy="360"/>
           </a:xfrm>
           <a:prstGeom prst="rect">
             <a:avLst/>
@@ -3384,7 +3444,7 @@
         <p:spPr>
           <a:xfrm>
             <a:off x="457200" y="457200"/>
-            <a:ext cx="10972440" cy="360"/>
+            <a:ext cx="10972080" cy="360"/>
           </a:xfrm>
           <a:prstGeom prst="rect">
             <a:avLst/>
@@ -3444,7 +3504,7 @@
         <p:spPr>
           <a:xfrm>
             <a:off x="731520" y="1280160"/>
-            <a:ext cx="10058040" cy="1828440"/>
+            <a:ext cx="10057680" cy="1828080"/>
           </a:xfrm>
           <a:prstGeom prst="rect">
             <a:avLst/>
@@ -3609,7 +3669,7 @@
         <p:spPr>
           <a:xfrm>
             <a:off x="731520" y="4114800"/>
-            <a:ext cx="10058040" cy="360"/>
+            <a:ext cx="10057680" cy="360"/>
           </a:xfrm>
           <a:prstGeom prst="rect">
             <a:avLst/>
@@ -3699,7 +3759,7 @@
         <p:spPr>
           <a:xfrm>
             <a:off x="457200" y="457200"/>
-            <a:ext cx="10972440" cy="360"/>
+            <a:ext cx="10972080" cy="360"/>
           </a:xfrm>
           <a:prstGeom prst="rect">
             <a:avLst/>
@@ -3759,7 +3819,7 @@
         <p:spPr>
           <a:xfrm>
             <a:off x="731520" y="1280160"/>
-            <a:ext cx="10058040" cy="1828440"/>
+            <a:ext cx="10057680" cy="1828080"/>
           </a:xfrm>
           <a:prstGeom prst="rect">
             <a:avLst/>
@@ -3819,7 +3879,7 @@
         <p:spPr>
           <a:xfrm>
             <a:off x="731520" y="4114800"/>
-            <a:ext cx="10058040" cy="360"/>
+            <a:ext cx="10057680" cy="360"/>
           </a:xfrm>
           <a:prstGeom prst="rect">
             <a:avLst/>
@@ -3909,7 +3969,7 @@
         <p:spPr>
           <a:xfrm>
             <a:off x="457200" y="457200"/>
-            <a:ext cx="10972440" cy="360"/>
+            <a:ext cx="10972080" cy="360"/>
           </a:xfrm>
           <a:prstGeom prst="rect">
             <a:avLst/>
@@ -3969,7 +4029,7 @@
         <p:spPr>
           <a:xfrm>
             <a:off x="731520" y="1280160"/>
-            <a:ext cx="10058040" cy="1828440"/>
+            <a:ext cx="10057680" cy="1828080"/>
           </a:xfrm>
           <a:prstGeom prst="rect">
             <a:avLst/>
@@ -4029,7 +4089,7 @@
         <p:spPr>
           <a:xfrm>
             <a:off x="731520" y="4114800"/>
-            <a:ext cx="10058040" cy="360"/>
+            <a:ext cx="10057680" cy="360"/>
           </a:xfrm>
           <a:prstGeom prst="rect">
             <a:avLst/>
@@ -4119,7 +4179,7 @@
         <p:spPr>
           <a:xfrm>
             <a:off x="457200" y="457200"/>
-            <a:ext cx="10972440" cy="360"/>
+            <a:ext cx="10972080" cy="360"/>
           </a:xfrm>
           <a:prstGeom prst="rect">
             <a:avLst/>
@@ -4157,7 +4217,7 @@
                 <a:uFillTx/>
                 <a:latin typeface="Calibri"/>
               </a:rPr>
-              <a:t>8. Bankomat</a:t>
+              <a:t>8. Bankomat (bonus / domácí úloha)</a:t>
             </a:r>
             <a:endParaRPr lang="en-US" sz="2400" b="0" u="none" strike="noStrike">
               <a:solidFill>
@@ -4179,7 +4239,7 @@
         <p:spPr>
           <a:xfrm>
             <a:off x="731520" y="1280160"/>
-            <a:ext cx="10058040" cy="1828440"/>
+            <a:ext cx="10057680" cy="1828080"/>
           </a:xfrm>
           <a:prstGeom prst="rect">
             <a:avLst/>
@@ -4239,7 +4299,7 @@
         <p:spPr>
           <a:xfrm>
             <a:off x="731520" y="4114800"/>
-            <a:ext cx="10058040" cy="360"/>
+            <a:ext cx="10057680" cy="360"/>
           </a:xfrm>
           <a:prstGeom prst="rect">
             <a:avLst/>

</xml_diff>